<commit_message>
Add class diagram relationships
Co-authored-by: slayqueearikma-beep <slayqueearikma-beep@users.noreply.github.com>
</commit_message>
<xml_diff>
--- a/presentation/AITDR_completed_after_slide_13.pptx
+++ b/presentation/AITDR_completed_after_slide_13.pptx
@@ -50400,7 +50400,567 @@
       </p:sp>
       <p:sp>
         <p:nvSpPr>
-          <p:cNvPr id="18" name="Rounded Rectangle 17"/>
+          <p:cNvPr id="18" name="Up Arrow 17"/>
+          <p:cNvSpPr/>
+          <p:nvPr/>
+        </p:nvSpPr>
+        <p:spPr>
+          <a:xfrm>
+            <a:off x="1572768" y="2816352"/>
+            <a:ext cx="164592" cy="384048"/>
+          </a:xfrm>
+          <a:prstGeom prst="upArrow">
+            <a:avLst/>
+          </a:prstGeom>
+          <a:solidFill>
+            <a:srgbClr val="7C96A0"/>
+          </a:solidFill>
+          <a:ln>
+            <a:solidFill>
+              <a:srgbClr val="7C96A0"/>
+            </a:solidFill>
+          </a:ln>
+        </p:spPr>
+        <p:style>
+          <a:lnRef idx="1">
+            <a:schemeClr val="accent1"/>
+          </a:lnRef>
+          <a:fillRef idx="3">
+            <a:schemeClr val="accent1"/>
+          </a:fillRef>
+          <a:effectRef idx="2">
+            <a:schemeClr val="accent1"/>
+          </a:effectRef>
+          <a:fontRef idx="minor">
+            <a:schemeClr val="lt1"/>
+          </a:fontRef>
+        </p:style>
+        <p:txBody>
+          <a:bodyPr rtlCol="0" anchor="ctr"/>
+          <a:lstStyle/>
+          <a:p>
+            <a:pPr algn="ctr"/>
+          </a:p>
+        </p:txBody>
+      </p:sp>
+      <p:sp>
+        <p:nvSpPr>
+          <p:cNvPr id="19" name="TextBox 18"/>
+          <p:cNvSpPr txBox="1"/>
+          <p:nvPr/>
+        </p:nvSpPr>
+        <p:spPr>
+          <a:xfrm>
+            <a:off x="1060704" y="2889504"/>
+            <a:ext cx="1097280" cy="164592"/>
+          </a:xfrm>
+          <a:prstGeom prst="rect">
+            <a:avLst/>
+          </a:prstGeom>
+          <a:noFill/>
+        </p:spPr>
+        <p:txBody>
+          <a:bodyPr wrap="square" lIns="0" rIns="0" tIns="0" bIns="0">
+            <a:spAutoFit/>
+          </a:bodyPr>
+          <a:lstStyle/>
+          <a:p>
+            <a:pPr algn="ctr"/>
+            <a:r>
+              <a:rPr sz="640" b="1" i="0">
+                <a:solidFill>
+                  <a:srgbClr val="7C96A0"/>
+                </a:solidFill>
+                <a:latin typeface="Aptos"/>
+              </a:rPr>
+              <a:t>capture 1..*</a:t>
+            </a:r>
+          </a:p>
+        </p:txBody>
+      </p:sp>
+      <p:sp>
+        <p:nvSpPr>
+          <p:cNvPr id="20" name="Right Arrow 19"/>
+          <p:cNvSpPr/>
+          <p:nvPr/>
+        </p:nvSpPr>
+        <p:spPr>
+          <a:xfrm>
+            <a:off x="2779776" y="2048256"/>
+            <a:ext cx="530352" cy="128016"/>
+          </a:xfrm>
+          <a:prstGeom prst="rightArrow">
+            <a:avLst/>
+          </a:prstGeom>
+          <a:solidFill>
+            <a:srgbClr val="7C96A0"/>
+          </a:solidFill>
+          <a:ln>
+            <a:solidFill>
+              <a:srgbClr val="7C96A0"/>
+            </a:solidFill>
+          </a:ln>
+        </p:spPr>
+        <p:style>
+          <a:lnRef idx="1">
+            <a:schemeClr val="accent1"/>
+          </a:lnRef>
+          <a:fillRef idx="3">
+            <a:schemeClr val="accent1"/>
+          </a:fillRef>
+          <a:effectRef idx="2">
+            <a:schemeClr val="accent1"/>
+          </a:effectRef>
+          <a:fontRef idx="minor">
+            <a:schemeClr val="lt1"/>
+          </a:fontRef>
+        </p:style>
+        <p:txBody>
+          <a:bodyPr rtlCol="0" anchor="ctr"/>
+          <a:lstStyle/>
+          <a:p>
+            <a:pPr algn="ctr"/>
+          </a:p>
+        </p:txBody>
+      </p:sp>
+      <p:sp>
+        <p:nvSpPr>
+          <p:cNvPr id="21" name="TextBox 20"/>
+          <p:cNvSpPr txBox="1"/>
+          <p:nvPr/>
+        </p:nvSpPr>
+        <p:spPr>
+          <a:xfrm>
+            <a:off x="2788920" y="1828800"/>
+            <a:ext cx="502920" cy="164592"/>
+          </a:xfrm>
+          <a:prstGeom prst="rect">
+            <a:avLst/>
+          </a:prstGeom>
+          <a:noFill/>
+        </p:spPr>
+        <p:txBody>
+          <a:bodyPr wrap="square" lIns="0" rIns="0" tIns="0" bIns="0">
+            <a:spAutoFit/>
+          </a:bodyPr>
+          <a:lstStyle/>
+          <a:p>
+            <a:pPr algn="ctr"/>
+            <a:r>
+              <a:rPr sz="640" b="1" i="0">
+                <a:solidFill>
+                  <a:srgbClr val="7C96A0"/>
+                </a:solidFill>
+                <a:latin typeface="Aptos"/>
+              </a:rPr>
+              <a:t>collecte</a:t>
+            </a:r>
+          </a:p>
+        </p:txBody>
+      </p:sp>
+      <p:sp>
+        <p:nvSpPr>
+          <p:cNvPr id="22" name="Down Arrow 21"/>
+          <p:cNvSpPr/>
+          <p:nvPr/>
+        </p:nvSpPr>
+        <p:spPr>
+          <a:xfrm>
+            <a:off x="4343400" y="2834640"/>
+            <a:ext cx="164592" cy="347472"/>
+          </a:xfrm>
+          <a:prstGeom prst="downArrow">
+            <a:avLst/>
+          </a:prstGeom>
+          <a:solidFill>
+            <a:srgbClr val="7C96A0"/>
+          </a:solidFill>
+          <a:ln>
+            <a:solidFill>
+              <a:srgbClr val="7C96A0"/>
+            </a:solidFill>
+          </a:ln>
+        </p:spPr>
+        <p:style>
+          <a:lnRef idx="1">
+            <a:schemeClr val="accent1"/>
+          </a:lnRef>
+          <a:fillRef idx="3">
+            <a:schemeClr val="accent1"/>
+          </a:fillRef>
+          <a:effectRef idx="2">
+            <a:schemeClr val="accent1"/>
+          </a:effectRef>
+          <a:fontRef idx="minor">
+            <a:schemeClr val="lt1"/>
+          </a:fontRef>
+        </p:style>
+        <p:txBody>
+          <a:bodyPr rtlCol="0" anchor="ctr"/>
+          <a:lstStyle/>
+          <a:p>
+            <a:pPr algn="ctr"/>
+          </a:p>
+        </p:txBody>
+      </p:sp>
+      <p:sp>
+        <p:nvSpPr>
+          <p:cNvPr id="23" name="TextBox 22"/>
+          <p:cNvSpPr txBox="1"/>
+          <p:nvPr/>
+        </p:nvSpPr>
+        <p:spPr>
+          <a:xfrm>
+            <a:off x="3977639" y="2907792"/>
+            <a:ext cx="868680" cy="164592"/>
+          </a:xfrm>
+          <a:prstGeom prst="rect">
+            <a:avLst/>
+          </a:prstGeom>
+          <a:noFill/>
+        </p:spPr>
+        <p:txBody>
+          <a:bodyPr wrap="square" lIns="0" rIns="0" tIns="0" bIns="0">
+            <a:spAutoFit/>
+          </a:bodyPr>
+          <a:lstStyle/>
+          <a:p>
+            <a:pPr algn="ctr"/>
+            <a:r>
+              <a:rPr sz="640" b="1" i="0">
+                <a:solidFill>
+                  <a:srgbClr val="7C96A0"/>
+                </a:solidFill>
+                <a:latin typeface="Aptos"/>
+              </a:rPr>
+              <a:t>analyse</a:t>
+            </a:r>
+          </a:p>
+        </p:txBody>
+      </p:sp>
+      <p:sp>
+        <p:nvSpPr>
+          <p:cNvPr id="24" name="Right Arrow 23"/>
+          <p:cNvSpPr/>
+          <p:nvPr/>
+        </p:nvSpPr>
+        <p:spPr>
+          <a:xfrm>
+            <a:off x="5577840" y="2048256"/>
+            <a:ext cx="530352" cy="128016"/>
+          </a:xfrm>
+          <a:prstGeom prst="rightArrow">
+            <a:avLst/>
+          </a:prstGeom>
+          <a:solidFill>
+            <a:srgbClr val="7C96A0"/>
+          </a:solidFill>
+          <a:ln>
+            <a:solidFill>
+              <a:srgbClr val="7C96A0"/>
+            </a:solidFill>
+          </a:ln>
+        </p:spPr>
+        <p:style>
+          <a:lnRef idx="1">
+            <a:schemeClr val="accent1"/>
+          </a:lnRef>
+          <a:fillRef idx="3">
+            <a:schemeClr val="accent1"/>
+          </a:fillRef>
+          <a:effectRef idx="2">
+            <a:schemeClr val="accent1"/>
+          </a:effectRef>
+          <a:fontRef idx="minor">
+            <a:schemeClr val="lt1"/>
+          </a:fontRef>
+        </p:style>
+        <p:txBody>
+          <a:bodyPr rtlCol="0" anchor="ctr"/>
+          <a:lstStyle/>
+          <a:p>
+            <a:pPr algn="ctr"/>
+          </a:p>
+        </p:txBody>
+      </p:sp>
+      <p:sp>
+        <p:nvSpPr>
+          <p:cNvPr id="25" name="TextBox 24"/>
+          <p:cNvSpPr txBox="1"/>
+          <p:nvPr/>
+        </p:nvSpPr>
+        <p:spPr>
+          <a:xfrm>
+            <a:off x="5577840" y="1828800"/>
+            <a:ext cx="548640" cy="164592"/>
+          </a:xfrm>
+          <a:prstGeom prst="rect">
+            <a:avLst/>
+          </a:prstGeom>
+          <a:noFill/>
+        </p:spPr>
+        <p:txBody>
+          <a:bodyPr wrap="square" lIns="0" rIns="0" tIns="0" bIns="0">
+            <a:spAutoFit/>
+          </a:bodyPr>
+          <a:lstStyle/>
+          <a:p>
+            <a:pPr algn="ctr"/>
+            <a:r>
+              <a:rPr sz="640" b="1" i="0">
+                <a:solidFill>
+                  <a:srgbClr val="7C96A0"/>
+                </a:solidFill>
+                <a:latin typeface="Aptos"/>
+              </a:rPr>
+              <a:t>alimente</a:t>
+            </a:r>
+          </a:p>
+        </p:txBody>
+      </p:sp>
+      <p:sp>
+        <p:nvSpPr>
+          <p:cNvPr id="26" name="Down Arrow 25"/>
+          <p:cNvSpPr/>
+          <p:nvPr/>
+        </p:nvSpPr>
+        <p:spPr>
+          <a:xfrm>
+            <a:off x="7150608" y="2834640"/>
+            <a:ext cx="164592" cy="347472"/>
+          </a:xfrm>
+          <a:prstGeom prst="downArrow">
+            <a:avLst/>
+          </a:prstGeom>
+          <a:solidFill>
+            <a:srgbClr val="7C96A0"/>
+          </a:solidFill>
+          <a:ln>
+            <a:solidFill>
+              <a:srgbClr val="7C96A0"/>
+            </a:solidFill>
+          </a:ln>
+        </p:spPr>
+        <p:style>
+          <a:lnRef idx="1">
+            <a:schemeClr val="accent1"/>
+          </a:lnRef>
+          <a:fillRef idx="3">
+            <a:schemeClr val="accent1"/>
+          </a:fillRef>
+          <a:effectRef idx="2">
+            <a:schemeClr val="accent1"/>
+          </a:effectRef>
+          <a:fontRef idx="minor">
+            <a:schemeClr val="lt1"/>
+          </a:fontRef>
+        </p:style>
+        <p:txBody>
+          <a:bodyPr rtlCol="0" anchor="ctr"/>
+          <a:lstStyle/>
+          <a:p>
+            <a:pPr algn="ctr"/>
+          </a:p>
+        </p:txBody>
+      </p:sp>
+      <p:sp>
+        <p:nvSpPr>
+          <p:cNvPr id="27" name="TextBox 26"/>
+          <p:cNvSpPr txBox="1"/>
+          <p:nvPr/>
+        </p:nvSpPr>
+        <p:spPr>
+          <a:xfrm>
+            <a:off x="6720840" y="2907792"/>
+            <a:ext cx="868680" cy="164592"/>
+          </a:xfrm>
+          <a:prstGeom prst="rect">
+            <a:avLst/>
+          </a:prstGeom>
+          <a:noFill/>
+        </p:spPr>
+        <p:txBody>
+          <a:bodyPr wrap="square" lIns="0" rIns="0" tIns="0" bIns="0">
+            <a:spAutoFit/>
+          </a:bodyPr>
+          <a:lstStyle/>
+          <a:p>
+            <a:pPr algn="ctr"/>
+            <a:r>
+              <a:rPr sz="640" b="1" i="0">
+                <a:solidFill>
+                  <a:srgbClr val="7C96A0"/>
+                </a:solidFill>
+                <a:latin typeface="Aptos"/>
+              </a:rPr>
+              <a:t>déclenche</a:t>
+            </a:r>
+          </a:p>
+        </p:txBody>
+      </p:sp>
+      <p:sp>
+        <p:nvSpPr>
+          <p:cNvPr id="28" name="Right Arrow 27"/>
+          <p:cNvSpPr/>
+          <p:nvPr/>
+        </p:nvSpPr>
+        <p:spPr>
+          <a:xfrm>
+            <a:off x="8366760" y="3803904"/>
+            <a:ext cx="502920" cy="128016"/>
+          </a:xfrm>
+          <a:prstGeom prst="rightArrow">
+            <a:avLst/>
+          </a:prstGeom>
+          <a:solidFill>
+            <a:srgbClr val="7C96A0"/>
+          </a:solidFill>
+          <a:ln>
+            <a:solidFill>
+              <a:srgbClr val="7C96A0"/>
+            </a:solidFill>
+          </a:ln>
+        </p:spPr>
+        <p:style>
+          <a:lnRef idx="1">
+            <a:schemeClr val="accent1"/>
+          </a:lnRef>
+          <a:fillRef idx="3">
+            <a:schemeClr val="accent1"/>
+          </a:fillRef>
+          <a:effectRef idx="2">
+            <a:schemeClr val="accent1"/>
+          </a:effectRef>
+          <a:fontRef idx="minor">
+            <a:schemeClr val="lt1"/>
+          </a:fontRef>
+        </p:style>
+        <p:txBody>
+          <a:bodyPr rtlCol="0" anchor="ctr"/>
+          <a:lstStyle/>
+          <a:p>
+            <a:pPr algn="ctr"/>
+          </a:p>
+        </p:txBody>
+      </p:sp>
+      <p:sp>
+        <p:nvSpPr>
+          <p:cNvPr id="29" name="TextBox 28"/>
+          <p:cNvSpPr txBox="1"/>
+          <p:nvPr/>
+        </p:nvSpPr>
+        <p:spPr>
+          <a:xfrm>
+            <a:off x="8321040" y="3584448"/>
+            <a:ext cx="685800" cy="164592"/>
+          </a:xfrm>
+          <a:prstGeom prst="rect">
+            <a:avLst/>
+          </a:prstGeom>
+          <a:noFill/>
+        </p:spPr>
+        <p:txBody>
+          <a:bodyPr wrap="square" lIns="0" rIns="0" tIns="0" bIns="0">
+            <a:spAutoFit/>
+          </a:bodyPr>
+          <a:lstStyle/>
+          <a:p>
+            <a:pPr algn="ctr"/>
+            <a:r>
+              <a:rPr sz="640" b="1" i="0">
+                <a:solidFill>
+                  <a:srgbClr val="7C96A0"/>
+                </a:solidFill>
+                <a:latin typeface="Aptos"/>
+              </a:rPr>
+              <a:t>crée règle</a:t>
+            </a:r>
+          </a:p>
+        </p:txBody>
+      </p:sp>
+      <p:sp>
+        <p:nvSpPr>
+          <p:cNvPr id="30" name="Right Arrow 29"/>
+          <p:cNvSpPr/>
+          <p:nvPr/>
+        </p:nvSpPr>
+        <p:spPr>
+          <a:xfrm>
+            <a:off x="8366760" y="4590288"/>
+            <a:ext cx="502920" cy="128016"/>
+          </a:xfrm>
+          <a:prstGeom prst="rightArrow">
+            <a:avLst/>
+          </a:prstGeom>
+          <a:solidFill>
+            <a:srgbClr val="7C96A0"/>
+          </a:solidFill>
+          <a:ln>
+            <a:solidFill>
+              <a:srgbClr val="7C96A0"/>
+            </a:solidFill>
+          </a:ln>
+        </p:spPr>
+        <p:style>
+          <a:lnRef idx="1">
+            <a:schemeClr val="accent1"/>
+          </a:lnRef>
+          <a:fillRef idx="3">
+            <a:schemeClr val="accent1"/>
+          </a:fillRef>
+          <a:effectRef idx="2">
+            <a:schemeClr val="accent1"/>
+          </a:effectRef>
+          <a:fontRef idx="minor">
+            <a:schemeClr val="lt1"/>
+          </a:fontRef>
+        </p:style>
+        <p:txBody>
+          <a:bodyPr rtlCol="0" anchor="ctr"/>
+          <a:lstStyle/>
+          <a:p>
+            <a:pPr algn="ctr"/>
+          </a:p>
+        </p:txBody>
+      </p:sp>
+      <p:sp>
+        <p:nvSpPr>
+          <p:cNvPr id="31" name="TextBox 30"/>
+          <p:cNvSpPr txBox="1"/>
+          <p:nvPr/>
+        </p:nvSpPr>
+        <p:spPr>
+          <a:xfrm>
+            <a:off x="8339327" y="4754880"/>
+            <a:ext cx="594360" cy="164592"/>
+          </a:xfrm>
+          <a:prstGeom prst="rect">
+            <a:avLst/>
+          </a:prstGeom>
+          <a:noFill/>
+        </p:spPr>
+        <p:txBody>
+          <a:bodyPr wrap="square" lIns="0" rIns="0" tIns="0" bIns="0">
+            <a:spAutoFit/>
+          </a:bodyPr>
+          <a:lstStyle/>
+          <a:p>
+            <a:pPr algn="ctr"/>
+            <a:r>
+              <a:rPr sz="640" b="1" i="0">
+                <a:solidFill>
+                  <a:srgbClr val="7C96A0"/>
+                </a:solidFill>
+                <a:latin typeface="Aptos"/>
+              </a:rPr>
+              <a:t>alimente</a:t>
+            </a:r>
+          </a:p>
+        </p:txBody>
+      </p:sp>
+      <p:sp>
+        <p:nvSpPr>
+          <p:cNvPr id="32" name="Rounded Rectangle 31"/>
           <p:cNvSpPr/>
           <p:nvPr/>
         </p:nvSpPr>
@@ -50445,7 +51005,7 @@
       </p:sp>
       <p:sp>
         <p:nvSpPr>
-          <p:cNvPr id="19" name="TextBox 18"/>
+          <p:cNvPr id="33" name="TextBox 32"/>
           <p:cNvSpPr txBox="1"/>
           <p:nvPr/>
         </p:nvSpPr>
@@ -50480,7 +51040,7 @@
       </p:sp>
       <p:sp>
         <p:nvSpPr>
-          <p:cNvPr id="20" name="TextBox 19"/>
+          <p:cNvPr id="34" name="TextBox 33"/>
           <p:cNvSpPr txBox="1"/>
           <p:nvPr/>
         </p:nvSpPr>
@@ -50518,7 +51078,7 @@
       </p:sp>
       <p:sp>
         <p:nvSpPr>
-          <p:cNvPr id="21" name="TextBox 20"/>
+          <p:cNvPr id="35" name="TextBox 34"/>
           <p:cNvSpPr txBox="1"/>
           <p:nvPr/>
         </p:nvSpPr>
@@ -50555,7 +51115,7 @@
       </p:sp>
       <p:sp>
         <p:nvSpPr>
-          <p:cNvPr id="22" name="Rounded Rectangle 21"/>
+          <p:cNvPr id="36" name="Rounded Rectangle 35"/>
           <p:cNvSpPr/>
           <p:nvPr/>
         </p:nvSpPr>
@@ -50600,7 +51160,7 @@
       </p:sp>
       <p:sp>
         <p:nvSpPr>
-          <p:cNvPr id="23" name="TextBox 22"/>
+          <p:cNvPr id="37" name="TextBox 36"/>
           <p:cNvSpPr txBox="1"/>
           <p:nvPr/>
         </p:nvSpPr>
@@ -50635,7 +51195,7 @@
       </p:sp>
       <p:sp>
         <p:nvSpPr>
-          <p:cNvPr id="24" name="TextBox 23"/>
+          <p:cNvPr id="38" name="TextBox 37"/>
           <p:cNvSpPr txBox="1"/>
           <p:nvPr/>
         </p:nvSpPr>
@@ -50673,7 +51233,7 @@
       </p:sp>
       <p:sp>
         <p:nvSpPr>
-          <p:cNvPr id="25" name="TextBox 24"/>
+          <p:cNvPr id="39" name="TextBox 38"/>
           <p:cNvSpPr txBox="1"/>
           <p:nvPr/>
         </p:nvSpPr>
@@ -50710,7 +51270,7 @@
       </p:sp>
       <p:sp>
         <p:nvSpPr>
-          <p:cNvPr id="26" name="Rounded Rectangle 25"/>
+          <p:cNvPr id="40" name="Rounded Rectangle 39"/>
           <p:cNvSpPr/>
           <p:nvPr/>
         </p:nvSpPr>
@@ -50755,7 +51315,7 @@
       </p:sp>
       <p:sp>
         <p:nvSpPr>
-          <p:cNvPr id="27" name="TextBox 26"/>
+          <p:cNvPr id="41" name="TextBox 40"/>
           <p:cNvSpPr txBox="1"/>
           <p:nvPr/>
         </p:nvSpPr>
@@ -50790,7 +51350,7 @@
       </p:sp>
       <p:sp>
         <p:nvSpPr>
-          <p:cNvPr id="28" name="TextBox 27"/>
+          <p:cNvPr id="42" name="TextBox 41"/>
           <p:cNvSpPr txBox="1"/>
           <p:nvPr/>
         </p:nvSpPr>
@@ -50828,7 +51388,7 @@
       </p:sp>
       <p:sp>
         <p:nvSpPr>
-          <p:cNvPr id="29" name="TextBox 28"/>
+          <p:cNvPr id="43" name="TextBox 42"/>
           <p:cNvSpPr txBox="1"/>
           <p:nvPr/>
         </p:nvSpPr>
@@ -50865,7 +51425,7 @@
       </p:sp>
       <p:sp>
         <p:nvSpPr>
-          <p:cNvPr id="30" name="Rounded Rectangle 29"/>
+          <p:cNvPr id="44" name="Rounded Rectangle 43"/>
           <p:cNvSpPr/>
           <p:nvPr/>
         </p:nvSpPr>
@@ -50910,7 +51470,7 @@
       </p:sp>
       <p:sp>
         <p:nvSpPr>
-          <p:cNvPr id="31" name="TextBox 30"/>
+          <p:cNvPr id="45" name="TextBox 44"/>
           <p:cNvSpPr txBox="1"/>
           <p:nvPr/>
         </p:nvSpPr>
@@ -50945,7 +51505,7 @@
       </p:sp>
       <p:sp>
         <p:nvSpPr>
-          <p:cNvPr id="32" name="TextBox 31"/>
+          <p:cNvPr id="46" name="TextBox 45"/>
           <p:cNvSpPr txBox="1"/>
           <p:nvPr/>
         </p:nvSpPr>
@@ -50982,7 +51542,7 @@
       </p:sp>
       <p:sp>
         <p:nvSpPr>
-          <p:cNvPr id="33" name="TextBox 32"/>
+          <p:cNvPr id="47" name="TextBox 46"/>
           <p:cNvSpPr txBox="1"/>
           <p:nvPr/>
         </p:nvSpPr>
@@ -51019,7 +51579,7 @@
       </p:sp>
       <p:sp>
         <p:nvSpPr>
-          <p:cNvPr id="34" name="Rounded Rectangle 33"/>
+          <p:cNvPr id="48" name="Rounded Rectangle 47"/>
           <p:cNvSpPr/>
           <p:nvPr/>
         </p:nvSpPr>
@@ -51064,7 +51624,7 @@
       </p:sp>
       <p:sp>
         <p:nvSpPr>
-          <p:cNvPr id="35" name="TextBox 34"/>
+          <p:cNvPr id="49" name="TextBox 48"/>
           <p:cNvSpPr txBox="1"/>
           <p:nvPr/>
         </p:nvSpPr>
@@ -51099,7 +51659,7 @@
       </p:sp>
       <p:sp>
         <p:nvSpPr>
-          <p:cNvPr id="36" name="TextBox 35"/>
+          <p:cNvPr id="50" name="TextBox 49"/>
           <p:cNvSpPr txBox="1"/>
           <p:nvPr/>
         </p:nvSpPr>
@@ -51137,7 +51697,7 @@
       </p:sp>
       <p:sp>
         <p:nvSpPr>
-          <p:cNvPr id="37" name="TextBox 36"/>
+          <p:cNvPr id="51" name="TextBox 50"/>
           <p:cNvSpPr txBox="1"/>
           <p:nvPr/>
         </p:nvSpPr>
@@ -51174,7 +51734,7 @@
       </p:sp>
       <p:sp>
         <p:nvSpPr>
-          <p:cNvPr id="38" name="Rounded Rectangle 37"/>
+          <p:cNvPr id="52" name="Rounded Rectangle 51"/>
           <p:cNvSpPr/>
           <p:nvPr/>
         </p:nvSpPr>
@@ -51219,7 +51779,7 @@
       </p:sp>
       <p:sp>
         <p:nvSpPr>
-          <p:cNvPr id="39" name="TextBox 38"/>
+          <p:cNvPr id="53" name="TextBox 52"/>
           <p:cNvSpPr txBox="1"/>
           <p:nvPr/>
         </p:nvSpPr>
@@ -51254,7 +51814,7 @@
       </p:sp>
       <p:sp>
         <p:nvSpPr>
-          <p:cNvPr id="40" name="TextBox 39"/>
+          <p:cNvPr id="54" name="TextBox 53"/>
           <p:cNvSpPr txBox="1"/>
           <p:nvPr/>
         </p:nvSpPr>
@@ -51292,7 +51852,7 @@
       </p:sp>
       <p:sp>
         <p:nvSpPr>
-          <p:cNvPr id="41" name="TextBox 40"/>
+          <p:cNvPr id="55" name="TextBox 54"/>
           <p:cNvSpPr txBox="1"/>
           <p:nvPr/>
         </p:nvSpPr>
@@ -51329,7 +51889,7 @@
       </p:sp>
       <p:sp>
         <p:nvSpPr>
-          <p:cNvPr id="42" name="Rounded Rectangle 41"/>
+          <p:cNvPr id="56" name="Rounded Rectangle 55"/>
           <p:cNvSpPr/>
           <p:nvPr/>
         </p:nvSpPr>
@@ -51374,7 +51934,7 @@
       </p:sp>
       <p:sp>
         <p:nvSpPr>
-          <p:cNvPr id="43" name="TextBox 42"/>
+          <p:cNvPr id="57" name="TextBox 56"/>
           <p:cNvSpPr txBox="1"/>
           <p:nvPr/>
         </p:nvSpPr>
@@ -51409,7 +51969,7 @@
       </p:sp>
       <p:sp>
         <p:nvSpPr>
-          <p:cNvPr id="44" name="TextBox 43"/>
+          <p:cNvPr id="58" name="TextBox 57"/>
           <p:cNvSpPr txBox="1"/>
           <p:nvPr/>
         </p:nvSpPr>
@@ -51447,7 +52007,7 @@
       </p:sp>
       <p:sp>
         <p:nvSpPr>
-          <p:cNvPr id="45" name="TextBox 44"/>
+          <p:cNvPr id="59" name="TextBox 58"/>
           <p:cNvSpPr txBox="1"/>
           <p:nvPr/>
         </p:nvSpPr>
@@ -51484,7 +52044,7 @@
       </p:sp>
       <p:sp>
         <p:nvSpPr>
-          <p:cNvPr id="46" name="Rounded Rectangle 45"/>
+          <p:cNvPr id="60" name="Rounded Rectangle 59"/>
           <p:cNvSpPr/>
           <p:nvPr/>
         </p:nvSpPr>
@@ -51529,7 +52089,7 @@
       </p:sp>
       <p:sp>
         <p:nvSpPr>
-          <p:cNvPr id="47" name="TextBox 46"/>
+          <p:cNvPr id="61" name="TextBox 60"/>
           <p:cNvSpPr txBox="1"/>
           <p:nvPr/>
         </p:nvSpPr>
@@ -51564,7 +52124,7 @@
       </p:sp>
       <p:sp>
         <p:nvSpPr>
-          <p:cNvPr id="48" name="TextBox 47"/>
+          <p:cNvPr id="62" name="TextBox 61"/>
           <p:cNvSpPr txBox="1"/>
           <p:nvPr/>
         </p:nvSpPr>
@@ -51601,7 +52161,7 @@
       </p:sp>
       <p:sp>
         <p:nvSpPr>
-          <p:cNvPr id="49" name="TextBox 48"/>
+          <p:cNvPr id="63" name="TextBox 62"/>
           <p:cNvSpPr txBox="1"/>
           <p:nvPr/>
         </p:nvSpPr>
@@ -51637,14 +52197,14 @@
       </p:sp>
       <p:sp>
         <p:nvSpPr>
-          <p:cNvPr id="50" name="TextBox 49"/>
+          <p:cNvPr id="64" name="TextBox 63"/>
           <p:cNvSpPr txBox="1"/>
           <p:nvPr/>
         </p:nvSpPr>
         <p:spPr>
           <a:xfrm>
-            <a:off x="914400" y="5806440"/>
-            <a:ext cx="10241280" cy="274320"/>
+            <a:off x="731520" y="5806440"/>
+            <a:ext cx="10789920" cy="274320"/>
           </a:xfrm>
           <a:prstGeom prst="rect">
             <a:avLst/>
@@ -51659,13 +52219,13 @@
           <a:p>
             <a:pPr algn="ctr"/>
             <a:r>
-              <a:rPr sz="1000" b="0" i="0">
+              <a:rPr sz="900" b="0" i="0">
                 <a:solidFill>
                   <a:srgbClr val="7C96A0"/>
                 </a:solidFill>
                 <a:latin typeface="Aptos"/>
               </a:rPr>
-              <a:t>Relations principales : AttackEvent -&gt; LogPipeline -&gt; SIEMAlert -&gt; SOARPlaybook -&gt; NSGRule</a:t>
+              <a:t>Relations : HoneypotVM capture AttackEvent ; LogPipeline collecte/analyse ; SIEMAlert déclenche SOARPlaybook ; SOARPlaybook crée NSGRule ; PowerBI visualise.</a:t>
             </a:r>
           </a:p>
         </p:txBody>

</xml_diff>